<commit_message>
Reframe the thesis slide to a reassurance, not a requirement
Slide 10 ("The thesis of this whole talk") previously read "Temporal
doesn't reward clever prompts. It rewards being explicit about failure,"
which reads as "you must spell everything out or it won't work." Replaced
with a more accurate, less intimidating message: you don't need to name
every retry/timer/signal up front to see what Temporal can do — a
sharper prompt just makes for a sharper demo.

Updated in both the HTML deck (slides/index.html + matching speaker
notes) and the editable pptx (pptx/build_pptx.py). Regenerated the PDF
and pptx exports, and re-ran the QA screenshot pass (34/34 slides render
cleanly).

Co-authored-by: Copilot <223556219+Copilot@users.noreply.github.com>
</commit_message>
<xml_diff>
--- a/presentation/Lifting-the-Veil-Temporal-Talk.pptx
+++ b/presentation/Lifting-the-Veil-Temporal-Talk.pptx
@@ -2285,7 +2285,7 @@
           <a:lstStyle/>
           <a:p>
             <a:r>
-              <a:t>Slow down here. Everything after is proof.</a:t>
+              <a:t>Slow down here. The refined prompt made this specific demo cleaner, but the takeaway isn't 'write a perfect spec or don't bother.' Even the rough first draft would have gotten a working workflow with retries and durability for free.</a:t>
             </a:r>
           </a:p>
         </p:txBody>
@@ -5756,7 +5756,7 @@
                 </a:solidFill>
                 <a:latin typeface="Segoe UI"/>
               </a:rPr>
-              <a:t>THE THESIS OF THIS WHOLE TALK</a:t>
+              <a:t>THE POINT OF THIS WHOLE TALK</a:t>
             </a:r>
           </a:p>
         </p:txBody>
@@ -5790,7 +5790,7 @@
                 </a:solidFill>
                 <a:latin typeface="Segoe UI"/>
               </a:rPr>
-              <a:t>Temporal doesn't reward clever prompts.
+              <a:t>Don't be overwhelmed.
 </a:t>
             </a:r>
             <a:r>
@@ -5800,7 +5800,7 @@
                 </a:solidFill>
                 <a:latin typeface="Segoe UI"/>
               </a:rPr>
-              <a:t>It rewards being </a:t>
+              <a:t>You don't need to spell everything out </a:t>
             </a:r>
             <a:r>
               <a:rPr sz="3200" b="1" i="0">
@@ -5809,7 +5809,7 @@
                 </a:solidFill>
                 <a:latin typeface="Segoe UI"/>
               </a:rPr>
-              <a:t>explicit about failure.</a:t>
+              <a:t>to see what Temporal can do for you.</a:t>
             </a:r>
           </a:p>
         </p:txBody>
@@ -5843,7 +5843,7 @@
                 </a:solidFill>
                 <a:latin typeface="Segoe UI"/>
               </a:rPr>
-              <a:t>Name the retries. Name the waits. Name what must survive a crash. The rest is implementation detail.</a:t>
+              <a:t>A sharper prompt makes for a sharper demo — but retries, signals, queries and durability are primitives Temporal gives you either way.</a:t>
             </a:r>
           </a:p>
         </p:txBody>

</xml_diff>

<commit_message>
Swap code/timeline slide to fraud-check workflow with real screenshot
- Replace the simplified claimWorkflow snippet with the actual
  fraud-check.workflow.ts body (proxyActivities call + the three
  activity invocations, two run in parallel) - no function wrapper,
  no return statement.
- Capture a real Temporal Web UI Timeline screenshot for a completed
  fraud-check child workflow execution, showing checkWatchlists and
  checkClaimHistory running concurrently followed by scoreFraudRisk.
- Update slide title to 'Three activity calls' and refresh speaker
  notes to describe the parallelism shown on the timeline.
- Mirror all changes in the pptx builder, rebuild pptx/PDF exports.
- Remove now-unused claim-workflow timeline screenshot.

Co-authored-by: Copilot <223556219+Copilot@users.noreply.github.com>
</commit_message>
<xml_diff>
--- a/presentation/Lifting-the-Veil-Temporal-Talk.pptx
+++ b/presentation/Lifting-the-Veil-Temporal-Talk.pptx
@@ -816,7 +816,7 @@
           <a:lstStyle/>
           <a:p>
             <a:r>
-              <a:t>This is the real Timeline tab from this app's Temporal Web UI, not a mockup. The code is intentionally stripped down to four sequential activity calls — the real claim.workflow.ts adds retries, a child workflow, timers and signals, and all of that shows up on this same timeline with zero extra instrumentation code.</a:t>
+              <a:t>This is the real Timeline tab for this app's fraud-check child workflow, not a mockup. The code on the left is the entire body — just a proxyActivities call and three activity invocations, two of them running in parallel. That parallelism is exactly what you see as two overlapping bars on the right, with zero extra instrumentation code.</a:t>
             </a:r>
           </a:p>
         </p:txBody>
@@ -8570,7 +8570,7 @@
                 </a:solidFill>
                 <a:latin typeface="Segoe UI"/>
               </a:rPr>
-              <a:t>Four activity calls. One real execution timeline.</a:t>
+              <a:t>Three activity calls. One real execution timeline.</a:t>
             </a:r>
           </a:p>
         </p:txBody>
@@ -8732,7 +8732,7 @@
                 </a:solidFill>
                 <a:latin typeface="Consolas"/>
               </a:rPr>
-              <a:t>●  ●  ●    claim.workflow.ts — simplified</a:t>
+              <a:t>●  ●  ●    fraud-check.workflow.ts — simplified</a:t>
             </a:r>
           </a:p>
         </p:txBody>
@@ -8771,13 +8771,13 @@
                 </a:solidFill>
                 <a:latin typeface="Consolas"/>
               </a:rPr>
-              <a:t>export async function claimWorkflow(input: ClaimInput) {
-  const validation = await validateClaim(input);
-  const coverage   = await verifyCoverage(input);
-  const damage     = await assessDamage(input);
-  const payment    = await processPayment(input);
-  return { validation, coverage, damage, payment };
-}</a:t>
+              <a:t>const { checkClaimHistory, checkWatchlists, scoreFraudRisk } =
+  proxyActivities&lt;typeof activities&gt;({ ...retryPolicy });
+const [history, watchlist] = await Promise.all([
+  checkClaimHistory(input),
+  checkWatchlists(input),
+]);
+const assessment = await scoreFraudRisk(input.claimId, [...history, ...watchlist]);</a:t>
             </a:r>
           </a:p>
         </p:txBody>
@@ -8912,7 +8912,7 @@
       </p:sp>
       <p:pic>
         <p:nvPicPr>
-          <p:cNvPr id="13" name="Picture 12" descr="temporal-timeline-example.png"/>
+          <p:cNvPr id="13" name="Picture 12" descr="temporal-timeline-fraud-example.png"/>
           <p:cNvPicPr>
             <a:picLocks noChangeAspect="1"/>
           </p:cNvPicPr>
@@ -8927,7 +8927,7 @@
         <p:spPr>
           <a:xfrm>
             <a:off x="6309360" y="2194560"/>
-            <a:ext cx="5120640" cy="2560320"/>
+            <a:ext cx="5120640" cy="1411765"/>
           </a:xfrm>
           <a:prstGeom prst="rect">
             <a:avLst/>

</xml_diff>

<commit_message>
Wrap fraud-check code example in the workflow function
Re-add the export async function fraudCheckWorkflow(...) wrapper
around the proxyActivities/activity-call snippet so the code example
reads as a complete, real workflow function rather than loose
statements. Rebuild pptx/PDF exports.

Co-authored-by: Copilot <223556219+Copilot@users.noreply.github.com>
</commit_message>
<xml_diff>
--- a/presentation/Lifting-the-Veil-Temporal-Talk.pptx
+++ b/presentation/Lifting-the-Veil-Temporal-Talk.pptx
@@ -8773,11 +8773,13 @@
               </a:rPr>
               <a:t>const { checkClaimHistory, checkWatchlists, scoreFraudRisk } =
   proxyActivities&lt;typeof activities&gt;({ ...retryPolicy });
-const [history, watchlist] = await Promise.all([
-  checkClaimHistory(input),
-  checkWatchlists(input),
-]);
-const assessment = await scoreFraudRisk(input.claimId, [...history, ...watchlist]);</a:t>
+export async function fraudCheckWorkflow(input: ClaimInput) {
+  const [history, watchlist] = await Promise.all([
+    checkClaimHistory(input),
+    checkWatchlists(input),
+  ]);
+  return await scoreFraudRisk(input.claimId, [...history, ...watchlist]);
+}</a:t>
             </a:r>
           </a:p>
         </p:txBody>

</xml_diff>

<commit_message>
Stack code and timeline screenshot vertically on fraud-check slide
- Switch the slide layout from side-by-side windows to stacked
  (code on top, Temporal Web UI screenshot below), giving the code
  block full slide width so lines no longer wrap and can be read at
  a larger, more comfortable font size.
- Add .stack-col layout and .window-body.code-compact (larger font)
  CSS classes.
- Rework code_and_image_slide() in the pptx builder to stack the two
  'windows' vertically and size the screenshot by height (centered)
  instead of stretching it to full card width.
- Rebuild pptx/PDF exports.

Co-authored-by: Copilot <223556219+Copilot@users.noreply.github.com>
</commit_message>
<xml_diff>
--- a/presentation/Lifting-the-Veil-Temporal-Talk.pptx
+++ b/presentation/Lifting-the-Veil-Temporal-Talk.pptx
@@ -8617,8 +8617,8 @@
         </p:nvSpPr>
         <p:spPr>
           <a:xfrm>
-            <a:off x="640080" y="1737360"/>
-            <a:ext cx="5303520" cy="3566160"/>
+            <a:off x="640080" y="1600200"/>
+            <a:ext cx="10881360" cy="2331720"/>
           </a:xfrm>
           <a:prstGeom prst="roundRect">
             <a:avLst>
@@ -8665,8 +8665,8 @@
         </p:nvSpPr>
         <p:spPr>
           <a:xfrm>
-            <a:off x="640080" y="1737360"/>
-            <a:ext cx="5303520" cy="365760"/>
+            <a:off x="640080" y="1600200"/>
+            <a:ext cx="10881360" cy="365760"/>
           </a:xfrm>
           <a:prstGeom prst="roundRect">
             <a:avLst/>
@@ -8711,8 +8711,8 @@
         </p:nvSpPr>
         <p:spPr>
           <a:xfrm>
-            <a:off x="777240" y="1792224"/>
-            <a:ext cx="5029200" cy="274320"/>
+            <a:off x="777240" y="1655064"/>
+            <a:ext cx="10607040" cy="274320"/>
           </a:xfrm>
           <a:prstGeom prst="rect">
             <a:avLst/>
@@ -8745,8 +8745,8 @@
         </p:nvSpPr>
         <p:spPr>
           <a:xfrm>
-            <a:off x="822960" y="2240280"/>
-            <a:ext cx="4937760" cy="2880360"/>
+            <a:off x="822960" y="2103120"/>
+            <a:ext cx="10515600" cy="1645920"/>
           </a:xfrm>
           <a:prstGeom prst="rect">
             <a:avLst/>
@@ -8765,20 +8765,28 @@
               </a:lnSpc>
             </a:pPr>
             <a:r>
-              <a:rPr sz="1300" b="0" i="0">
+              <a:rPr sz="1600" b="0" i="0">
                 <a:solidFill>
                   <a:srgbClr val="D6DCF5"/>
                 </a:solidFill>
                 <a:latin typeface="Consolas"/>
               </a:rPr>
-              <a:t>const { checkClaimHistory, checkWatchlists, scoreFraudRisk } =
-  proxyActivities&lt;typeof activities&gt;({ ...retryPolicy });
-export async function fraudCheckWorkflow(input: ClaimInput) {
+              <a:t>const {
+  checkClaimHistory,
+  checkWatchlists,
+  scoreFraudRisk,
+} = proxyActivities&lt;typeof activities&gt;({ ...retryPolicy });
+export async function fraudCheckWorkflow(
+  input: ClaimInput,
+) {
   const [history, watchlist] = await Promise.all([
     checkClaimHistory(input),
     checkWatchlists(input),
   ]);
-  return await scoreFraudRisk(input.claimId, [...history, ...watchlist]);
+  return await scoreFraudRisk(
+    input.claimId,
+    [...history, ...watchlist],
+  );
 }</a:t>
             </a:r>
           </a:p>
@@ -8792,8 +8800,8 @@
         </p:nvSpPr>
         <p:spPr>
           <a:xfrm>
-            <a:off x="6217920" y="1737360"/>
-            <a:ext cx="5303520" cy="3566160"/>
+            <a:off x="640080" y="4160520"/>
+            <a:ext cx="10881360" cy="2331720"/>
           </a:xfrm>
           <a:prstGeom prst="roundRect">
             <a:avLst>
@@ -8840,8 +8848,8 @@
         </p:nvSpPr>
         <p:spPr>
           <a:xfrm>
-            <a:off x="6217920" y="1737360"/>
-            <a:ext cx="5303520" cy="365760"/>
+            <a:off x="640080" y="4160520"/>
+            <a:ext cx="10881360" cy="365760"/>
           </a:xfrm>
           <a:prstGeom prst="roundRect">
             <a:avLst/>
@@ -8886,8 +8894,8 @@
         </p:nvSpPr>
         <p:spPr>
           <a:xfrm>
-            <a:off x="6355080" y="1792224"/>
-            <a:ext cx="5029200" cy="274320"/>
+            <a:off x="777240" y="4215384"/>
+            <a:ext cx="10607040" cy="274320"/>
           </a:xfrm>
           <a:prstGeom prst="rect">
             <a:avLst/>
@@ -8928,8 +8936,8 @@
         </p:blipFill>
         <p:spPr>
           <a:xfrm>
-            <a:off x="6309360" y="2194560"/>
-            <a:ext cx="5120640" cy="1411765"/>
+            <a:off x="2929955" y="4617720"/>
+            <a:ext cx="6301611" cy="1737360"/>
           </a:xfrm>
           <a:prstGeom prst="rect">
             <a:avLst/>
@@ -8944,7 +8952,7 @@
         </p:nvSpPr>
         <p:spPr>
           <a:xfrm>
-            <a:off x="640080" y="5532120"/>
+            <a:off x="640080" y="6675120"/>
             <a:ext cx="10515600" cy="1097280"/>
           </a:xfrm>
           <a:prstGeom prst="rect">

</xml_diff>

<commit_message>
Shrink code/timeline windows on fraud-check slide to fit slide height
- HTML: narrow both stacked windows to 62% width, tighten gaps/margins
  so the note text below no longer gets clipped by the slide bottom.
- pptx: narrow the two card widths to 9in (centered) and shorten their
  heights to match, resize the screenshot and code font accordingly.
- Rebuild pptx/PDF exports.

Co-authored-by: Copilot <223556219+Copilot@users.noreply.github.com>
</commit_message>
<xml_diff>
--- a/presentation/Lifting-the-Veil-Temporal-Talk.pptx
+++ b/presentation/Lifting-the-Veil-Temporal-Talk.pptx
@@ -8617,8 +8617,8 @@
         </p:nvSpPr>
         <p:spPr>
           <a:xfrm>
-            <a:off x="640080" y="1600200"/>
-            <a:ext cx="10881360" cy="2331720"/>
+            <a:off x="1979676" y="1600200"/>
+            <a:ext cx="8229600" cy="2148840"/>
           </a:xfrm>
           <a:prstGeom prst="roundRect">
             <a:avLst>
@@ -8665,8 +8665,8 @@
         </p:nvSpPr>
         <p:spPr>
           <a:xfrm>
-            <a:off x="640080" y="1600200"/>
-            <a:ext cx="10881360" cy="365760"/>
+            <a:off x="1979676" y="1600200"/>
+            <a:ext cx="8229600" cy="365760"/>
           </a:xfrm>
           <a:prstGeom prst="roundRect">
             <a:avLst/>
@@ -8711,8 +8711,8 @@
         </p:nvSpPr>
         <p:spPr>
           <a:xfrm>
-            <a:off x="777240" y="1655064"/>
-            <a:ext cx="10607040" cy="274320"/>
+            <a:off x="2116836" y="1655064"/>
+            <a:ext cx="7955280" cy="274320"/>
           </a:xfrm>
           <a:prstGeom prst="rect">
             <a:avLst/>
@@ -8745,8 +8745,8 @@
         </p:nvSpPr>
         <p:spPr>
           <a:xfrm>
-            <a:off x="822960" y="2103120"/>
-            <a:ext cx="10515600" cy="1645920"/>
+            <a:off x="2162556" y="2103120"/>
+            <a:ext cx="7863840" cy="1463040"/>
           </a:xfrm>
           <a:prstGeom prst="rect">
             <a:avLst/>
@@ -8765,7 +8765,7 @@
               </a:lnSpc>
             </a:pPr>
             <a:r>
-              <a:rPr sz="1600" b="0" i="0">
+              <a:rPr sz="1200" b="0" i="0">
                 <a:solidFill>
                   <a:srgbClr val="D6DCF5"/>
                 </a:solidFill>
@@ -8800,8 +8800,8 @@
         </p:nvSpPr>
         <p:spPr>
           <a:xfrm>
-            <a:off x="640080" y="4160520"/>
-            <a:ext cx="10881360" cy="2331720"/>
+            <a:off x="1979676" y="3931920"/>
+            <a:ext cx="8229600" cy="1965960"/>
           </a:xfrm>
           <a:prstGeom prst="roundRect">
             <a:avLst>
@@ -8848,8 +8848,8 @@
         </p:nvSpPr>
         <p:spPr>
           <a:xfrm>
-            <a:off x="640080" y="4160520"/>
-            <a:ext cx="10881360" cy="365760"/>
+            <a:off x="1979676" y="3931920"/>
+            <a:ext cx="8229600" cy="365760"/>
           </a:xfrm>
           <a:prstGeom prst="roundRect">
             <a:avLst/>
@@ -8894,8 +8894,8 @@
         </p:nvSpPr>
         <p:spPr>
           <a:xfrm>
-            <a:off x="777240" y="4215384"/>
-            <a:ext cx="10607040" cy="274320"/>
+            <a:off x="2116836" y="3986784"/>
+            <a:ext cx="7955280" cy="274320"/>
           </a:xfrm>
           <a:prstGeom prst="rect">
             <a:avLst/>
@@ -8936,8 +8936,8 @@
         </p:blipFill>
         <p:spPr>
           <a:xfrm>
-            <a:off x="2929955" y="4617720"/>
-            <a:ext cx="6301611" cy="1737360"/>
+            <a:off x="3606998" y="4389120"/>
+            <a:ext cx="4974956" cy="1371600"/>
           </a:xfrm>
           <a:prstGeom prst="rect">
             <a:avLst/>
@@ -8952,7 +8952,7 @@
         </p:nvSpPr>
         <p:spPr>
           <a:xfrm>
-            <a:off x="640080" y="6675120"/>
+            <a:off x="640080" y="6080760"/>
             <a:ext cx="10515600" cy="1097280"/>
           </a:xfrm>
           <a:prstGeom prst="rect">

</xml_diff>

<commit_message>
Fix pptx code text mismatch causing overflow on fraud-check slide
The pptx builder still had the old, longer wrapped-line code snippet
(never updated to match the shorter HTML version), which overflowed
its card and pushed the screenshot/note text off-slide. Update the
code text to match the compact HTML version and rebalance card
heights so everything fits cleanly within the slide bounds. Verified
by exporting the actual .pptx to PDF via PowerPoint and rendering the
slide to an image.

Co-authored-by: Copilot <223556219+Copilot@users.noreply.github.com>
</commit_message>
<xml_diff>
--- a/presentation/Lifting-the-Veil-Temporal-Talk.pptx
+++ b/presentation/Lifting-the-Veil-Temporal-Talk.pptx
@@ -8617,8 +8617,8 @@
         </p:nvSpPr>
         <p:spPr>
           <a:xfrm>
-            <a:off x="1979676" y="1600200"/>
-            <a:ext cx="8229600" cy="2148840"/>
+            <a:off x="1979676" y="1463040"/>
+            <a:ext cx="8229600" cy="2788920"/>
           </a:xfrm>
           <a:prstGeom prst="roundRect">
             <a:avLst>
@@ -8665,7 +8665,7 @@
         </p:nvSpPr>
         <p:spPr>
           <a:xfrm>
-            <a:off x="1979676" y="1600200"/>
+            <a:off x="1979676" y="1463040"/>
             <a:ext cx="8229600" cy="365760"/>
           </a:xfrm>
           <a:prstGeom prst="roundRect">
@@ -8711,7 +8711,7 @@
         </p:nvSpPr>
         <p:spPr>
           <a:xfrm>
-            <a:off x="2116836" y="1655064"/>
+            <a:off x="2116836" y="1517904"/>
             <a:ext cx="7955280" cy="274320"/>
           </a:xfrm>
           <a:prstGeom prst="rect">
@@ -8745,8 +8745,8 @@
         </p:nvSpPr>
         <p:spPr>
           <a:xfrm>
-            <a:off x="2162556" y="2103120"/>
-            <a:ext cx="7863840" cy="1463040"/>
+            <a:off x="2162556" y="1965960"/>
+            <a:ext cx="7863840" cy="2103120"/>
           </a:xfrm>
           <a:prstGeom prst="rect">
             <a:avLst/>
@@ -8771,22 +8771,14 @@
                 </a:solidFill>
                 <a:latin typeface="Consolas"/>
               </a:rPr>
-              <a:t>const {
-  checkClaimHistory,
-  checkWatchlists,
-  scoreFraudRisk,
-} = proxyActivities&lt;typeof activities&gt;({ ...retryPolicy });
-export async function fraudCheckWorkflow(
-  input: ClaimInput,
-) {
+              <a:t>const { checkClaimHistory, checkWatchlists, scoreFraudRisk } =
+  proxyActivities&lt;typeof activities&gt;({ ...retryPolicy });
+export async function fraudCheckWorkflow(input: ClaimInput) {
   const [history, watchlist] = await Promise.all([
     checkClaimHistory(input),
     checkWatchlists(input),
   ]);
-  return await scoreFraudRisk(
-    input.claimId,
-    [...history, ...watchlist],
-  );
+  return await scoreFraudRisk(input.claimId, [...history, ...watchlist]);
 }</a:t>
             </a:r>
           </a:p>
@@ -8800,8 +8792,8 @@
         </p:nvSpPr>
         <p:spPr>
           <a:xfrm>
-            <a:off x="1979676" y="3931920"/>
-            <a:ext cx="8229600" cy="1965960"/>
+            <a:off x="1979676" y="4343400"/>
+            <a:ext cx="8229600" cy="1463040"/>
           </a:xfrm>
           <a:prstGeom prst="roundRect">
             <a:avLst>
@@ -8848,7 +8840,7 @@
         </p:nvSpPr>
         <p:spPr>
           <a:xfrm>
-            <a:off x="1979676" y="3931920"/>
+            <a:off x="1979676" y="4343400"/>
             <a:ext cx="8229600" cy="365760"/>
           </a:xfrm>
           <a:prstGeom prst="roundRect">
@@ -8894,7 +8886,7 @@
         </p:nvSpPr>
         <p:spPr>
           <a:xfrm>
-            <a:off x="2116836" y="3986784"/>
+            <a:off x="2116836" y="4398264"/>
             <a:ext cx="7955280" cy="274320"/>
           </a:xfrm>
           <a:prstGeom prst="rect">
@@ -8936,8 +8928,8 @@
         </p:blipFill>
         <p:spPr>
           <a:xfrm>
-            <a:off x="3606998" y="4389120"/>
-            <a:ext cx="4974956" cy="1371600"/>
+            <a:off x="4519073" y="4800600"/>
+            <a:ext cx="3150805" cy="868680"/>
           </a:xfrm>
           <a:prstGeom prst="rect">
             <a:avLst/>
@@ -8952,7 +8944,7 @@
         </p:nvSpPr>
         <p:spPr>
           <a:xfrm>
-            <a:off x="640080" y="6080760"/>
+            <a:off x="640080" y="5989320"/>
             <a:ext cx="10515600" cy="1097280"/>
           </a:xfrm>
           <a:prstGeom prst="rect">

</xml_diff>